<commit_message>
Why We Are Here: add profit-generating activities and working on vs in the business
Co-Authored-By: Claude Opus 5.5 <noreply@anthropic.com>
Claude-Session: https://claude.ai/code/session_01Xa4nFVxuQGXmHARGph9WhS
</commit_message>
<xml_diff>
--- a/day2-deck/decks/Talking Points - Day 2.pptx
+++ b/day2-deck/decks/Talking Points - Day 2.pptx
@@ -516,7 +516,8 @@
             <a:r>
               <a:rPr lang="en-US" dirty="0"/>
               <a:t>Source: Talking points: Service Manager Roundtable (Nov 15, 2024) and GM meeting decks (Jan and May 2026). Data: Qlik (Profit &amp; Loss, Closed Repair Orders, Productivity), Jan-Sep 2026 vs 2025, same-store, 33 stores, INEOS excluded.PLACE: right after the cover, before the Gross section.
-Said: Roundtable slides 2, 5, 7, 6 (objective; philosophy &amp; culture; 'you get what you tolerate'; collaboration). Ask adapted from Roundtable slide 24 closing questions.</a:t>
+Said: Roundtable slides 2, 5, 7, 6 (objective; philosophy &amp; culture; 'you get what you tolerate'; collaboration). Ask adapted from Roundtable slide 24 closing questions.
+Added Oct 22 (Noah): profit-generating activities and incremental dollars; working on the business versus in it.</a:t>
             </a:r>
             <a:endParaRPr lang="en-US" dirty="0"/>
           </a:p>
@@ -2275,7 +2276,7 @@
               <a:buChar char="•"/>
             </a:pPr>
             <a:r>
-              <a:rPr lang="en-US" sz="1800" dirty="0">
+              <a:rPr lang="en-US" sz="1600" dirty="0">
                 <a:solidFill>
                   <a:srgbClr val="1A1A1A"/>
                 </a:solidFill>
@@ -2285,7 +2286,7 @@
               </a:rPr>
               <a:t>Foster collaboration, introduce ideas that drive operational excellence, and set a clear path to exceptional service performance</a:t>
             </a:r>
-            <a:endParaRPr lang="en-US" sz="1800" dirty="0"/>
+            <a:endParaRPr lang="en-US" sz="1600" dirty="0"/>
           </a:p>
           <a:p>
             <a:pPr marL="228600" indent="-228600">
@@ -2296,17 +2297,17 @@
               <a:buChar char="•"/>
             </a:pPr>
             <a:r>
-              <a:rPr lang="en-US" sz="1800" dirty="0">
-                <a:solidFill>
-                  <a:srgbClr val="1A1A1A"/>
-                </a:solidFill>
-                <a:latin typeface="Inter" pitchFamily="34" charset="0"/>
-                <a:ea typeface="Inter" pitchFamily="34" charset="-122"/>
-                <a:cs typeface="Inter" pitchFamily="34" charset="-120"/>
-              </a:rPr>
-              <a:t>No risk of judgement: your success is our success</a:t>
-            </a:r>
-            <a:endParaRPr lang="en-US" sz="1800" dirty="0"/>
+              <a:rPr lang="en-US" sz="1600" dirty="0">
+                <a:solidFill>
+                  <a:srgbClr val="1A1A1A"/>
+                </a:solidFill>
+                <a:latin typeface="Inter" pitchFamily="34" charset="0"/>
+                <a:ea typeface="Inter" pitchFamily="34" charset="-122"/>
+                <a:cs typeface="Inter" pitchFamily="34" charset="-120"/>
+              </a:rPr>
+              <a:t>Focus on profit-generating activities: the work that brings in incremental dollars, not just the work that fills the day</a:t>
+            </a:r>
+            <a:endParaRPr lang="en-US" sz="1600" dirty="0"/>
           </a:p>
           <a:p>
             <a:pPr marL="228600" indent="-228600">
@@ -2317,17 +2318,17 @@
               <a:buChar char="•"/>
             </a:pPr>
             <a:r>
-              <a:rPr lang="en-US" sz="1800" dirty="0">
-                <a:solidFill>
-                  <a:srgbClr val="1A1A1A"/>
-                </a:solidFill>
-                <a:latin typeface="Inter" pitchFamily="34" charset="0"/>
-                <a:ea typeface="Inter" pitchFamily="34" charset="-122"/>
-                <a:cs typeface="Inter" pitchFamily="34" charset="-120"/>
-              </a:rPr>
-              <a:t>Customer first, company second, team third</a:t>
-            </a:r>
-            <a:endParaRPr lang="en-US" sz="1800" dirty="0"/>
+              <a:rPr lang="en-US" sz="1600" dirty="0">
+                <a:solidFill>
+                  <a:srgbClr val="1A1A1A"/>
+                </a:solidFill>
+                <a:latin typeface="Inter" pitchFamily="34" charset="0"/>
+                <a:ea typeface="Inter" pitchFamily="34" charset="-122"/>
+                <a:cs typeface="Inter" pitchFamily="34" charset="-120"/>
+              </a:rPr>
+              <a:t>Work on the business, not just in it: step out of the daily fires long enough to fix the process behind them</a:t>
+            </a:r>
+            <a:endParaRPr lang="en-US" sz="1600" dirty="0"/>
           </a:p>
           <a:p>
             <a:pPr marL="228600" indent="-228600">
@@ -2338,17 +2339,17 @@
               <a:buChar char="•"/>
             </a:pPr>
             <a:r>
-              <a:rPr lang="en-US" sz="1800" dirty="0">
-                <a:solidFill>
-                  <a:srgbClr val="1A1A1A"/>
-                </a:solidFill>
-                <a:latin typeface="Inter" pitchFamily="34" charset="0"/>
-                <a:ea typeface="Inter" pitchFamily="34" charset="-122"/>
-                <a:cs typeface="Inter" pitchFamily="34" charset="-120"/>
-              </a:rPr>
-              <a:t>You get what you tolerate</a:t>
-            </a:r>
-            <a:endParaRPr lang="en-US" sz="1800" dirty="0"/>
+              <a:rPr lang="en-US" sz="1600" dirty="0">
+                <a:solidFill>
+                  <a:srgbClr val="1A1A1A"/>
+                </a:solidFill>
+                <a:latin typeface="Inter" pitchFamily="34" charset="0"/>
+                <a:ea typeface="Inter" pitchFamily="34" charset="-122"/>
+                <a:cs typeface="Inter" pitchFamily="34" charset="-120"/>
+              </a:rPr>
+              <a:t>No risk of judgement: your success is our success</a:t>
+            </a:r>
+            <a:endParaRPr lang="en-US" sz="1600" dirty="0"/>
           </a:p>
           <a:p>
             <a:pPr marL="228600" indent="-228600">
@@ -2359,7 +2360,49 @@
               <a:buChar char="•"/>
             </a:pPr>
             <a:r>
-              <a:rPr lang="en-US" sz="1800" dirty="0">
+              <a:rPr lang="en-US" sz="1600" dirty="0">
+                <a:solidFill>
+                  <a:srgbClr val="1A1A1A"/>
+                </a:solidFill>
+                <a:latin typeface="Inter" pitchFamily="34" charset="0"/>
+                <a:ea typeface="Inter" pitchFamily="34" charset="-122"/>
+                <a:cs typeface="Inter" pitchFamily="34" charset="-120"/>
+              </a:rPr>
+              <a:t>Customer first, company second, team third</a:t>
+            </a:r>
+            <a:endParaRPr lang="en-US" sz="1600" dirty="0"/>
+          </a:p>
+          <a:p>
+            <a:pPr marL="228600" indent="-228600">
+              <a:spcAft>
+                <a:spcPts val="800"/>
+              </a:spcAft>
+              <a:buSzPct val="100000"/>
+              <a:buChar char="•"/>
+            </a:pPr>
+            <a:r>
+              <a:rPr lang="en-US" sz="1600" dirty="0">
+                <a:solidFill>
+                  <a:srgbClr val="1A1A1A"/>
+                </a:solidFill>
+                <a:latin typeface="Inter" pitchFamily="34" charset="0"/>
+                <a:ea typeface="Inter" pitchFamily="34" charset="-122"/>
+                <a:cs typeface="Inter" pitchFamily="34" charset="-120"/>
+              </a:rPr>
+              <a:t>You get what you tolerate</a:t>
+            </a:r>
+            <a:endParaRPr lang="en-US" sz="1600" dirty="0"/>
+          </a:p>
+          <a:p>
+            <a:pPr marL="228600" indent="-228600">
+              <a:spcAft>
+                <a:spcPts val="800"/>
+              </a:spcAft>
+              <a:buSzPct val="100000"/>
+              <a:buChar char="•"/>
+            </a:pPr>
+            <a:r>
+              <a:rPr lang="en-US" sz="1600" dirty="0">
                 <a:solidFill>
                   <a:srgbClr val="1A1A1A"/>
                 </a:solidFill>
@@ -2369,7 +2412,7 @@
               </a:rPr>
               <a:t>Leverage the power in this room: collaboration</a:t>
             </a:r>
-            <a:endParaRPr lang="en-US" sz="1800" dirty="0"/>
+            <a:endParaRPr lang="en-US" sz="1600" dirty="0"/>
           </a:p>
         </p:txBody>
       </p:sp>

</xml_diff>

<commit_message>
Warranty rate increases: Honda North at $463,396, group $3,788,200; call it added gross profit
Co-Authored-By: Claude Opus 5.5 <noreply@anthropic.com>
Claude-Session: https://claude.ai/code/session_01Xa4nFVxuQGXmHARGph9WhS
</commit_message>
<xml_diff>
--- a/day2-deck/decks/Talking Points - Day 2.pptx
+++ b/day2-deck/decks/Talking Points - Day 2.pptx
@@ -605,7 +605,7 @@
           <a:p>
             <a:r>
               <a:rPr lang="en-US" dirty="0"/>
-              <a:t>Source: Talking points: Service Manager Roundtable (Nov 15, 2024) and GM meeting decks (Jan and May 2026). Data: Qlik (Profit &amp; Loss, Closed Repair Orders, Productivity), Jan-Sep 2026 vs 2025, same-store, 33 stores, INEOS excluded.PLACE: Warranty &amp; Internal section, after the section break, ahead of Warranty Rate Increases (Oct 22: $3,788,100 from the YTD RWR Financials vendor report replaced the warranty RO count here).
+              <a:t>Source: Talking points: Service Manager Roundtable (Nov 15, 2024) and GM meeting decks (Jan and May 2026). Data: Qlik (Profit &amp; Loss, Closed Repair Orders, Productivity), Jan-Sep 2026 vs 2025, same-store, 33 stores, INEOS excluded.PLACE: Warranty &amp; Internal section, after the section break, ahead of Warranty Rate Increases (Oct 22: $3,788,200 added gross profit from the YTD RWR Financials vendor report replaced the warranty RO count here).
 Said: Jan GM slides 13-14 (audit chargebacks; Warranty Compliance). The Jan slide named six stores' chargebacks; kept to the $400,000 total here, in line with no store call-outs from the podium.</a:t>
             </a:r>
             <a:endParaRPr lang="en-US" dirty="0"/>
@@ -3186,7 +3186,7 @@
                 <a:ea typeface="Inter" pitchFamily="34" charset="-122"/>
                 <a:cs typeface="Inter" pitchFamily="34" charset="-120"/>
               </a:rPr>
-              <a:t>$3,788,100</a:t>
+              <a:t>$3,788,200</a:t>
             </a:r>
             <a:endParaRPr lang="en-US" sz="3000" dirty="0"/>
           </a:p>
@@ -3225,7 +3225,7 @@
                 <a:ea typeface="Inter" pitchFamily="34" charset="-122"/>
                 <a:cs typeface="Inter" pitchFamily="34" charset="-120"/>
               </a:rPr>
-              <a:t>Secured so far this year from approved warranty labor and parts rate increases, 19 stores (vendor YTD report).</a:t>
+              <a:t>Added gross profit from warranty labor and parts rate increases approved this year, 19 stores.</a:t>
             </a:r>
             <a:endParaRPr lang="en-US" sz="1400" dirty="0"/>
           </a:p>

</xml_diff>

<commit_message>
Tracking & Accountability: drop the 15.2% figure; Warranty Compliance: parts reimbursement and warranty parts GP %
Co-Authored-By: Claude Opus 5.5 <noreply@anthropic.com>
Claude-Session: https://claude.ai/code/session_01Xa4nFVxuQGXmHARGph9WhS
</commit_message>
<xml_diff>
--- a/day2-deck/decks/Talking Points - Day 2.pptx
+++ b/day2-deck/decks/Talking Points - Day 2.pptx
@@ -3041,7 +3041,7 @@
                 <a:ea typeface="Inter" pitchFamily="34" charset="-122"/>
                 <a:cs typeface="Inter" pitchFamily="34" charset="-120"/>
               </a:rPr>
-              <a:t>Higher labor rates and tariffs are driving up OEM scrutiny</a:t>
+              <a:t>Higher labor rates, higher parts reimbursement and tariffs are driving up OEM scrutiny</a:t>
             </a:r>
             <a:endParaRPr lang="en-US" sz="1800" dirty="0"/>
           </a:p>
@@ -3140,7 +3140,7 @@
         <p:spPr>
           <a:xfrm>
             <a:off x="7269480" y="1920240"/>
-            <a:ext cx="54864" cy="1783080"/>
+            <a:ext cx="54864" cy="1112520"/>
           </a:xfrm>
           <a:prstGeom prst="rect">
             <a:avLst/>
@@ -3201,7 +3201,7 @@
         <p:spPr>
           <a:xfrm>
             <a:off x="7452360" y="2441448"/>
-            <a:ext cx="4023360" cy="1280160"/>
+            <a:ext cx="4023360" cy="609600"/>
           </a:xfrm>
           <a:prstGeom prst="rect">
             <a:avLst/>
@@ -3239,8 +3239,8 @@
         </p:nvSpPr>
         <p:spPr>
           <a:xfrm>
-            <a:off x="7269480" y="3931920"/>
-            <a:ext cx="54864" cy="1783080"/>
+            <a:off x="7269480" y="3261360"/>
+            <a:ext cx="54864" cy="1112520"/>
           </a:xfrm>
           <a:prstGeom prst="rect">
             <a:avLst/>
@@ -3259,7 +3259,7 @@
         </p:nvSpPr>
         <p:spPr>
           <a:xfrm>
-            <a:off x="7452360" y="3886200"/>
+            <a:off x="7452360" y="3215640"/>
             <a:ext cx="4023360" cy="566928"/>
           </a:xfrm>
           <a:prstGeom prst="rect">
@@ -3300,8 +3300,8 @@
         </p:nvSpPr>
         <p:spPr>
           <a:xfrm>
-            <a:off x="7452360" y="4453128"/>
-            <a:ext cx="4023360" cy="1280160"/>
+            <a:off x="7452360" y="3782568"/>
+            <a:ext cx="4023360" cy="609600"/>
           </a:xfrm>
           <a:prstGeom prst="rect">
             <a:avLst/>
@@ -3339,6 +3339,106 @@
         </p:nvSpPr>
         <p:spPr>
           <a:xfrm>
+            <a:off x="7269480" y="4602480"/>
+            <a:ext cx="54864" cy="1112520"/>
+          </a:xfrm>
+          <a:prstGeom prst="rect">
+            <a:avLst/>
+          </a:prstGeom>
+          <a:solidFill>
+            <a:srgbClr val="12A566"/>
+          </a:solidFill>
+          <a:ln/>
+        </p:spPr>
+      </p:sp>
+      <p:sp>
+        <p:nvSpPr>
+          <p:cNvPr id="17" name="Text 15"/>
+          <p:cNvSpPr txBox="1"/>
+          <p:nvPr/>
+        </p:nvSpPr>
+        <p:spPr>
+          <a:xfrm>
+            <a:off x="7452360" y="4556760"/>
+            <a:ext cx="4023360" cy="566928"/>
+          </a:xfrm>
+          <a:prstGeom prst="rect">
+            <a:avLst/>
+          </a:prstGeom>
+          <a:noFill/>
+          <a:ln/>
+        </p:spPr>
+        <p:txBody>
+          <a:bodyPr wrap="square" lIns="0" tIns="0" rIns="0" bIns="0" rtlCol="0" anchor="ctr">
+            <a:normAutofit/>
+          </a:bodyPr>
+          <a:lstStyle/>
+          <a:p>
+            <a:pPr indent="0" marL="0">
+              <a:buNone/>
+            </a:pPr>
+            <a:r>
+              <a:rPr lang="en-US" sz="3000" b="1" dirty="0">
+                <a:solidFill>
+                  <a:srgbClr val="0B7A4A"/>
+                </a:solidFill>
+                <a:latin typeface="Inter" pitchFamily="34" charset="0"/>
+                <a:ea typeface="Inter" pitchFamily="34" charset="-122"/>
+                <a:cs typeface="Inter" pitchFamily="34" charset="-120"/>
+              </a:rPr>
+              <a:t>44.7%</a:t>
+            </a:r>
+            <a:endParaRPr lang="en-US" sz="3000" dirty="0"/>
+          </a:p>
+        </p:txBody>
+      </p:sp>
+      <p:sp>
+        <p:nvSpPr>
+          <p:cNvPr id="18" name="Text 16"/>
+          <p:cNvSpPr txBox="1"/>
+          <p:nvPr/>
+        </p:nvSpPr>
+        <p:spPr>
+          <a:xfrm>
+            <a:off x="7452360" y="5123688"/>
+            <a:ext cx="4023360" cy="609600"/>
+          </a:xfrm>
+          <a:prstGeom prst="rect">
+            <a:avLst/>
+          </a:prstGeom>
+          <a:noFill/>
+          <a:ln/>
+        </p:spPr>
+        <p:txBody>
+          <a:bodyPr wrap="square" lIns="0" tIns="0" rIns="0" bIns="0" rtlCol="0" anchor="t"/>
+          <a:lstStyle/>
+          <a:p>
+            <a:pPr indent="0" marL="0">
+              <a:buNone/>
+            </a:pPr>
+            <a:r>
+              <a:rPr lang="en-US" sz="1400" dirty="0">
+                <a:solidFill>
+                  <a:srgbClr val="1A1A1A"/>
+                </a:solidFill>
+                <a:latin typeface="Inter" pitchFamily="34" charset="0"/>
+                <a:ea typeface="Inter" pitchFamily="34" charset="-122"/>
+                <a:cs typeface="Inter" pitchFamily="34" charset="-120"/>
+              </a:rPr>
+              <a:t>Warranty parts gross profit, up 2.1 pts and ahead of 2025 in all nine months.</a:t>
+            </a:r>
+            <a:endParaRPr lang="en-US" sz="1400" dirty="0"/>
+          </a:p>
+        </p:txBody>
+      </p:sp>
+      <p:sp>
+        <p:nvSpPr>
+          <p:cNvPr id="19" name="Shape 17"/>
+          <p:cNvSpPr/>
+          <p:nvPr/>
+        </p:nvSpPr>
+        <p:spPr>
+          <a:xfrm>
             <a:off x="457200" y="6126480"/>
             <a:ext cx="11274552" cy="371856"/>
           </a:xfrm>
@@ -3353,7 +3453,7 @@
       </p:sp>
       <p:sp>
         <p:nvSpPr>
-          <p:cNvPr id="17" name="Text 15"/>
+          <p:cNvPr id="20" name="Text 18"/>
           <p:cNvSpPr txBox="1"/>
           <p:nvPr/>
         </p:nvSpPr>
@@ -10442,13 +10542,13 @@
         <p:spPr>
           <a:xfrm>
             <a:off x="7269480" y="1920240"/>
-            <a:ext cx="54864" cy="1783080"/>
-          </a:xfrm>
-          <a:prstGeom prst="rect">
-            <a:avLst/>
-          </a:prstGeom>
-          <a:solidFill>
-            <a:srgbClr val="12A566"/>
+            <a:ext cx="54864" cy="3794760"/>
+          </a:xfrm>
+          <a:prstGeom prst="rect">
+            <a:avLst/>
+          </a:prstGeom>
+          <a:solidFill>
+            <a:srgbClr val="C2352F"/>
           </a:solidFill>
           <a:ln/>
         </p:spPr>
@@ -10482,13 +10582,13 @@
             <a:r>
               <a:rPr lang="en-US" sz="3000" b="1" dirty="0">
                 <a:solidFill>
-                  <a:srgbClr val="0B7A4A"/>
-                </a:solidFill>
-                <a:latin typeface="Inter" pitchFamily="34" charset="0"/>
-                <a:ea typeface="Inter" pitchFamily="34" charset="-122"/>
-                <a:cs typeface="Inter" pitchFamily="34" charset="-120"/>
-              </a:rPr>
-              <a:t>15.2%</a:t>
+                  <a:srgbClr val="A82B26"/>
+                </a:solidFill>
+                <a:latin typeface="Inter" pitchFamily="34" charset="0"/>
+                <a:ea typeface="Inter" pitchFamily="34" charset="-122"/>
+                <a:cs typeface="Inter" pitchFamily="34" charset="-120"/>
+              </a:rPr>
+              <a:t>4.2% to 63.5%</a:t>
             </a:r>
             <a:endParaRPr lang="en-US" sz="3000" dirty="0"/>
           </a:p>
@@ -10503,7 +10603,7 @@
         <p:spPr>
           <a:xfrm>
             <a:off x="7452360" y="2441448"/>
-            <a:ext cx="4023360" cy="1280160"/>
+            <a:ext cx="4023360" cy="3291840"/>
           </a:xfrm>
           <a:prstGeom prst="rect">
             <a:avLst/>
@@ -10527,7 +10627,7 @@
                 <a:ea typeface="Inter" pitchFamily="34" charset="-122"/>
                 <a:cs typeface="Inter" pitchFamily="34" charset="-120"/>
               </a:rPr>
-              <a:t>Customer-pay labor whose op code description can't be classified, down from 19.0%.</a:t>
+              <a:t>Share of each store's customer-pay labor whose op code description doesn't say what was sold. Vague descriptions hide what the shop sells.</a:t>
             </a:r>
             <a:endParaRPr lang="en-US" sz="1400" dirty="0"/>
           </a:p>
@@ -10541,106 +10641,6 @@
         </p:nvSpPr>
         <p:spPr>
           <a:xfrm>
-            <a:off x="7269480" y="3931920"/>
-            <a:ext cx="54864" cy="1783080"/>
-          </a:xfrm>
-          <a:prstGeom prst="rect">
-            <a:avLst/>
-          </a:prstGeom>
-          <a:solidFill>
-            <a:srgbClr val="C2352F"/>
-          </a:solidFill>
-          <a:ln/>
-        </p:spPr>
-      </p:sp>
-      <p:sp>
-        <p:nvSpPr>
-          <p:cNvPr id="14" name="Text 12"/>
-          <p:cNvSpPr txBox="1"/>
-          <p:nvPr/>
-        </p:nvSpPr>
-        <p:spPr>
-          <a:xfrm>
-            <a:off x="7452360" y="3886200"/>
-            <a:ext cx="4023360" cy="566928"/>
-          </a:xfrm>
-          <a:prstGeom prst="rect">
-            <a:avLst/>
-          </a:prstGeom>
-          <a:noFill/>
-          <a:ln/>
-        </p:spPr>
-        <p:txBody>
-          <a:bodyPr wrap="square" lIns="0" tIns="0" rIns="0" bIns="0" rtlCol="0" anchor="ctr">
-            <a:normAutofit/>
-          </a:bodyPr>
-          <a:lstStyle/>
-          <a:p>
-            <a:pPr indent="0" marL="0">
-              <a:buNone/>
-            </a:pPr>
-            <a:r>
-              <a:rPr lang="en-US" sz="3000" b="1" dirty="0">
-                <a:solidFill>
-                  <a:srgbClr val="A82B26"/>
-                </a:solidFill>
-                <a:latin typeface="Inter" pitchFamily="34" charset="0"/>
-                <a:ea typeface="Inter" pitchFamily="34" charset="-122"/>
-                <a:cs typeface="Inter" pitchFamily="34" charset="-120"/>
-              </a:rPr>
-              <a:t>4.2% to 63.5%</a:t>
-            </a:r>
-            <a:endParaRPr lang="en-US" sz="3000" dirty="0"/>
-          </a:p>
-        </p:txBody>
-      </p:sp>
-      <p:sp>
-        <p:nvSpPr>
-          <p:cNvPr id="15" name="Text 13"/>
-          <p:cNvSpPr txBox="1"/>
-          <p:nvPr/>
-        </p:nvSpPr>
-        <p:spPr>
-          <a:xfrm>
-            <a:off x="7452360" y="4453128"/>
-            <a:ext cx="4023360" cy="1280160"/>
-          </a:xfrm>
-          <a:prstGeom prst="rect">
-            <a:avLst/>
-          </a:prstGeom>
-          <a:noFill/>
-          <a:ln/>
-        </p:spPr>
-        <p:txBody>
-          <a:bodyPr wrap="square" lIns="0" tIns="0" rIns="0" bIns="0" rtlCol="0" anchor="t"/>
-          <a:lstStyle/>
-          <a:p>
-            <a:pPr indent="0" marL="0">
-              <a:buNone/>
-            </a:pPr>
-            <a:r>
-              <a:rPr lang="en-US" sz="1400" dirty="0">
-                <a:solidFill>
-                  <a:srgbClr val="1A1A1A"/>
-                </a:solidFill>
-                <a:latin typeface="Inter" pitchFamily="34" charset="0"/>
-                <a:ea typeface="Inter" pitchFamily="34" charset="-122"/>
-                <a:cs typeface="Inter" pitchFamily="34" charset="-120"/>
-              </a:rPr>
-              <a:t>The range across stores. Vague descriptions hide what the shop sells.</a:t>
-            </a:r>
-            <a:endParaRPr lang="en-US" sz="1400" dirty="0"/>
-          </a:p>
-        </p:txBody>
-      </p:sp>
-      <p:sp>
-        <p:nvSpPr>
-          <p:cNvPr id="16" name="Shape 14"/>
-          <p:cNvSpPr/>
-          <p:nvPr/>
-        </p:nvSpPr>
-        <p:spPr>
-          <a:xfrm>
             <a:off x="457200" y="6126480"/>
             <a:ext cx="11274552" cy="615696"/>
           </a:xfrm>
@@ -10655,7 +10655,7 @@
       </p:sp>
       <p:sp>
         <p:nvSpPr>
-          <p:cNvPr id="17" name="Text 15"/>
+          <p:cNvPr id="14" name="Text 12"/>
           <p:cNvSpPr txBox="1"/>
           <p:nvPr/>
         </p:nvSpPr>

</xml_diff>

<commit_message>
ELR charts show cents; MPI completion on Tracking & Accountability; Supporting evidence on What Gets Claims Debited
Co-Authored-By: Claude Opus 5.5 <noreply@anthropic.com>
Claude-Session: https://claude.ai/code/session_01Xa4nFVxuQGXmHARGph9WhS
</commit_message>
<xml_diff>
--- a/day2-deck/decks/Talking Points - Day 2.pptx
+++ b/day2-deck/decks/Talking Points - Day 2.pptx
@@ -10588,7 +10588,7 @@
                 <a:ea typeface="Inter" pitchFamily="34" charset="-122"/>
                 <a:cs typeface="Inter" pitchFamily="34" charset="-120"/>
               </a:rPr>
-              <a:t>4.2% to 63.5%</a:t>
+              <a:t>81.3%</a:t>
             </a:r>
             <a:endParaRPr lang="en-US" sz="3000" dirty="0"/>
           </a:p>
@@ -10627,7 +10627,7 @@
                 <a:ea typeface="Inter" pitchFamily="34" charset="-122"/>
                 <a:cs typeface="Inter" pitchFamily="34" charset="-120"/>
               </a:rPr>
-              <a:t>Share of each store's customer-pay labor whose op code description doesn't say what was sold. Vague descriptions hide what the shop sells.</a:t>
+              <a:t>MPI completion, July to September (store-reported). 12 of 33 stores at the 90% benchmark.</a:t>
             </a:r>
             <a:endParaRPr lang="en-US" sz="1400" dirty="0"/>
           </a:p>

</xml_diff>

<commit_message>
Pricing Strategy: gap-to-70% opportunity replaces the grid vs non-grid tile
Co-Authored-By: Claude Opus 5.5 <noreply@anthropic.com>
Claude-Session: https://claude.ai/code/session_01Xa4nFVxuQGXmHARGph9WhS
</commit_message>
<xml_diff>
--- a/day2-deck/decks/Talking Points - Day 2.pptx
+++ b/day2-deck/decks/Talking Points - Day 2.pptx
@@ -1321,7 +1321,8 @@
             <a:r>
               <a:rPr lang="en-US" dirty="0"/>
               <a:t>Source: Talking points: Service Manager Roundtable (Nov 15, 2024) and GM meeting decks (Jan and May 2026). Data: Qlik (Profit &amp; Loss, Closed Repair Orders, Productivity), Jan-Sep 2026 vs 2025, same-store, 33 stores, INEOS excluded.PLACE: CP Engine section, before the CP ELR slides (ahead of the door-rate options).
-Said: Roundtable slide 15 (Pricing Strategy); Jan/May GM Road to the Sale slide (pricing lines); Jan GM slide 54 (Discounting Discipline); 70% benchmark from the Jan/May door rate slides.</a:t>
+Said: Roundtable slide 15 (Pricing Strategy); Jan/May GM Road to the Sale slide (pricing lines); Jan GM slide 54 (Discounting Discipline); 70% benchmark from the Jan/May door rate slides.
+Oct 23 (Noah): grid vs non-grid tile replaced. $126,831 a month = Jul-Sep, for each of the 8 stores under 70% (Chevy LV, Toyota Spokane, Cadillac, Kia LV, Subaru Prescott, Lincoln, GMC Prescott, Hyundai Prescott): (70% x door rate - CP ELR) x CP hours sold, summed ($380,494) / 3. Door rates from the store door rate sheet (door.json), ELR and hours from elr_q3.json.</a:t>
             </a:r>
             <a:endParaRPr lang="en-US" dirty="0"/>
           </a:p>
@@ -8845,7 +8846,7 @@
             <a:avLst/>
           </a:prstGeom>
           <a:solidFill>
-            <a:srgbClr val="C2352F"/>
+            <a:srgbClr val="2587C5"/>
           </a:solidFill>
           <a:ln/>
         </p:spPr>
@@ -8879,13 +8880,13 @@
             <a:r>
               <a:rPr lang="en-US" sz="3000" b="1" dirty="0">
                 <a:solidFill>
-                  <a:srgbClr val="A82B26"/>
-                </a:solidFill>
-                <a:latin typeface="Inter" pitchFamily="34" charset="0"/>
-                <a:ea typeface="Inter" pitchFamily="34" charset="-122"/>
-                <a:cs typeface="Inter" pitchFamily="34" charset="-120"/>
-              </a:rPr>
-              <a:t>73.9% vs 76.4%</a:t>
+                  <a:srgbClr val="0B2C4A"/>
+                </a:solidFill>
+                <a:latin typeface="Inter" pitchFamily="34" charset="0"/>
+                <a:ea typeface="Inter" pitchFamily="34" charset="-122"/>
+                <a:cs typeface="Inter" pitchFamily="34" charset="-120"/>
+              </a:rPr>
+              <a:t>$127K a month</a:t>
             </a:r>
             <a:endParaRPr lang="en-US" sz="3000" dirty="0"/>
           </a:p>
@@ -8924,7 +8925,7 @@
                 <a:ea typeface="Inter" pitchFamily="34" charset="-122"/>
                 <a:cs typeface="Inter" pitchFamily="34" charset="-120"/>
               </a:rPr>
-              <a:t>Grid stores realize less of their door rate than flat-rate stores, Jul-Sep.</a:t>
+              <a:t>Added labor if the 8 stores under 70% reached it on the hours they already sell, Jul-Sep: $126,831 a month.</a:t>
             </a:r>
             <a:endParaRPr lang="en-US" sz="1400" dirty="0"/>
           </a:p>

</xml_diff>

<commit_message>
Day 2 deck: Why We Are Here with fixed ops share of group net profit in the deck
Co-Authored-By: Claude Opus 5.5 <noreply@anthropic.com>
Claude-Session: https://claude.ai/code/session_01Xa4nFVxuQGXmHARGph9WhS
</commit_message>
<xml_diff>
--- a/day2-deck/decks/Talking Points - Day 2.pptx
+++ b/day2-deck/decks/Talking Points - Day 2.pptx
@@ -515,9 +515,7 @@
           <a:p>
             <a:r>
               <a:rPr lang="en-US" dirty="0"/>
-              <a:t>Source: Talking points: Service Manager Roundtable (Nov 15, 2024) and GM meeting decks (Jan and May 2026). Data: Qlik (Profit &amp; Loss, Closed Repair Orders, Productivity), Jan-Sep 2026 vs 2025, same-store, 33 stores, INEOS excluded.PLACE: right after the cover, before the Gross section.
-Said: Roundtable slides 2, 5, 7, 6 (objective; philosophy &amp; culture; 'you get what you tolerate'; collaboration). Ask adapted from Roundtable slide 24 closing questions.
-Added Oct 22 (Noah): profit-generating activities and incremental dollars; working on the business versus in it.</a:t>
+              <a:t>Source: Qlik - Profit &amp; Loss, Jan-Sep 2026 vs 2025, all stores (INEOS included, to match the group P&amp;L). Fixed ops = service (Mechanical) + parts (P&amp;A) department profit: department gross less the department's own expenses. Group net = Net Profit Or Loss on the GM statement.PLACE: right after the agenda, before the Gross section. In the deck Oct 24 (Noah): group net profit view replaces the gross / absorption / net-to-gross tiles. Group-level view of fixed ops' weight in the dealership's profit, Jan-Sep. Fixed ops department profit $50,194,950 (2025 $45,336,135); group net profit $82,240,434 (2025 $95,664,709). On the P&amp;L, F&amp;I income, other income and store-level costs are not split by department, so 'the rest of the store' is the group net less fixed ops department profit. Group net = Net Profit Or Loss on the GM statement (P&amp;L summary), all stores; INEOS (opened 2026) is in both lines. Body shop (GMC Prescott) department profit is left out of fixed ops, as everywhere in the deck.</a:t>
             </a:r>
             <a:endParaRPr lang="en-US" dirty="0"/>
           </a:p>
@@ -2472,7 +2470,7 @@
                 <a:ea typeface="Inter" pitchFamily="34" charset="-122"/>
                 <a:cs typeface="Inter" pitchFamily="34" charset="-120"/>
               </a:rPr>
-              <a:t>+$7,468,567</a:t>
+              <a:t>61%</a:t>
             </a:r>
             <a:endParaRPr lang="en-US" sz="3000" dirty="0"/>
           </a:p>
@@ -2511,7 +2509,7 @@
                 <a:ea typeface="Inter" pitchFamily="34" charset="-122"/>
                 <a:cs typeface="Inter" pitchFamily="34" charset="-120"/>
               </a:rPr>
-              <a:t>Fixed ops gross, up 4.1% year to date. 25 of 33 stores grew.</a:t>
+              <a:t>of the group's net profit came from service and parts: $50.19M of $82.24M (47% in 2025).</a:t>
             </a:r>
             <a:endParaRPr lang="en-US" sz="1400" dirty="0"/>
           </a:p>
@@ -2532,7 +2530,7 @@
             <a:avLst/>
           </a:prstGeom>
           <a:solidFill>
-            <a:srgbClr val="12A566"/>
+            <a:srgbClr val="2587C5"/>
           </a:solidFill>
           <a:ln/>
         </p:spPr>
@@ -2566,13 +2564,13 @@
             <a:r>
               <a:rPr lang="en-US" sz="3000" b="1" dirty="0">
                 <a:solidFill>
-                  <a:srgbClr val="0B7A4A"/>
-                </a:solidFill>
-                <a:latin typeface="Inter" pitchFamily="34" charset="0"/>
-                <a:ea typeface="Inter" pitchFamily="34" charset="-122"/>
-                <a:cs typeface="Inter" pitchFamily="34" charset="-120"/>
-              </a:rPr>
-              <a:t>78.1%</a:t>
+                  <a:srgbClr val="0B2C4A"/>
+                </a:solidFill>
+                <a:latin typeface="Inter" pitchFamily="34" charset="0"/>
+                <a:ea typeface="Inter" pitchFamily="34" charset="-122"/>
+                <a:cs typeface="Inter" pitchFamily="34" charset="-120"/>
+              </a:rPr>
+              <a:t>$50.19M</a:t>
             </a:r>
             <a:endParaRPr lang="en-US" sz="3000" dirty="0"/>
           </a:p>
@@ -2611,7 +2609,7 @@
                 <a:ea typeface="Inter" pitchFamily="34" charset="-122"/>
                 <a:cs typeface="Inter" pitchFamily="34" charset="-120"/>
               </a:rPr>
-              <a:t>Fixed ops absorption, up 2.1 pts. Fixed gross grew 4.1%, fixed expenses 1.3%.</a:t>
+              <a:t>Fixed ops department profit. New, used, F&amp;I and the rest of the store together: $32.05M.</a:t>
             </a:r>
             <a:endParaRPr lang="en-US" sz="1400" dirty="0"/>
           </a:p>
@@ -2672,7 +2670,7 @@
                 <a:ea typeface="Inter" pitchFamily="34" charset="-122"/>
                 <a:cs typeface="Inter" pitchFamily="34" charset="-120"/>
               </a:rPr>
-              <a:t>21.8%</a:t>
+              <a:t>+$4,858,815</a:t>
             </a:r>
             <a:endParaRPr lang="en-US" sz="3000" dirty="0"/>
           </a:p>
@@ -2711,7 +2709,7 @@
                 <a:ea typeface="Inter" pitchFamily="34" charset="-122"/>
                 <a:cs typeface="Inter" pitchFamily="34" charset="-120"/>
               </a:rPr>
-              <a:t>Service net to gross, up 2.9 pts and ahead of 2025 in all nine months.</a:t>
+              <a:t>More fixed ops profit than 2025, while group net profit fell $13.42M.</a:t>
             </a:r>
             <a:endParaRPr lang="en-US" sz="1400" dirty="0"/>
           </a:p>
@@ -2732,7 +2730,7 @@
             <a:avLst/>
           </a:prstGeom>
           <a:solidFill>
-            <a:srgbClr val="E6F6EE"/>
+            <a:srgbClr val="EDF4FA"/>
           </a:solidFill>
           <a:ln/>
         </p:spPr>
@@ -2764,7 +2762,7 @@
             <a:r>
               <a:rPr lang="en-US" sz="1600" b="1" dirty="0">
                 <a:solidFill>
-                  <a:srgbClr val="0B7A4A"/>
+                  <a:srgbClr val="0B2C4A"/>
                 </a:solidFill>
                 <a:latin typeface="Inter" pitchFamily="34" charset="0"/>
                 <a:ea typeface="Inter" pitchFamily="34" charset="-122"/>

</xml_diff>

<commit_message>
Before You Leave: benchmark total tile, commitments reviewed next meeting
Co-Authored-By: Claude Opus 5.5 <noreply@anthropic.com>
Claude-Session: https://claude.ai/code/session_01Xa4nFVxuQGXmHARGph9WhS
</commit_message>
<xml_diff>
--- a/day2-deck/decks/Talking Points - Day 2.pptx
+++ b/day2-deck/decks/Talking Points - Day 2.pptx
@@ -964,7 +964,7 @@
             <a:r>
               <a:rPr lang="en-US" dirty="0"/>
               <a:t>Source: Talking points: Service Manager Roundtable (Nov 15, 2024) and GM meeting decks (Jan and May 2026). Data: Qlik (Profit &amp; Loss, Closed Repair Orders, Productivity), Jan-Sep 2026 vs 2025, same-store, 33 stores, INEOS excluded.PLACE: the close, after the last Productivity / Proficiency slide.
-Said: Roundtable slide 24 (Misc &amp; Closing). Commitments tracking was dropped for this meeting, so this asks for commitments without a scorecard.</a:t>
+Said: Roundtable slide 24 (Misc &amp; Closing). Commitments are reviewed at the next meeting (Noah, Oct 27): keep a list of what each store names.</a:t>
             </a:r>
             <a:endParaRPr lang="en-US" dirty="0"/>
           </a:p>
@@ -6046,6 +6046,27 @@
             </a:r>
             <a:endParaRPr lang="en-US" sz="1800" dirty="0"/>
           </a:p>
+          <a:p>
+            <a:pPr marL="228600" indent="-228600">
+              <a:spcAft>
+                <a:spcPts val="800"/>
+              </a:spcAft>
+              <a:buSzPct val="100000"/>
+              <a:buChar char="•"/>
+            </a:pPr>
+            <a:r>
+              <a:rPr lang="en-US" sz="1800" dirty="0">
+                <a:solidFill>
+                  <a:srgbClr val="1A1A1A"/>
+                </a:solidFill>
+                <a:latin typeface="Inter" pitchFamily="34" charset="0"/>
+                <a:ea typeface="Inter" pitchFamily="34" charset="-122"/>
+                <a:cs typeface="Inter" pitchFamily="34" charset="-120"/>
+              </a:rPr>
+              <a:t>We will review your commitments at the next meeting</a:t>
+            </a:r>
+            <a:endParaRPr lang="en-US" sz="1800" dirty="0"/>
+          </a:p>
         </p:txBody>
       </p:sp>
       <p:sp>
@@ -6203,7 +6224,7 @@
                 <a:ea typeface="Inter" pitchFamily="34" charset="-122"/>
                 <a:cs typeface="Inter" pitchFamily="34" charset="-120"/>
               </a:rPr>
-              <a:t>18,493 balances</a:t>
+              <a:t>$4.9M a year</a:t>
             </a:r>
             <a:endParaRPr lang="en-US" sz="3000" dirty="0"/>
           </a:p>
@@ -6242,7 +6263,7 @@
                 <a:ea typeface="Inter" pitchFamily="34" charset="-122"/>
                 <a:cs typeface="Inter" pitchFamily="34" charset="-120"/>
               </a:rPr>
-              <a:t>The largest benchmark gap, at 8.3% against 15%.</a:t>
+              <a:t>Every store at all four opcode benchmarks: $4,895,199 in labor and parts gross.</a:t>
             </a:r>
             <a:endParaRPr lang="en-US" sz="1400" dirty="0"/>
           </a:p>

</xml_diff>

<commit_message>
Tracking & Accountability ahead of the inspection slides with MPI, video and photo tiles
Co-Authored-By: Claude Opus 5.5 <noreply@anthropic.com>
Claude-Session: https://claude.ai/code/session_01Xa4nFVxuQGXmHARGph9WhS
</commit_message>
<xml_diff>
--- a/day2-deck/decks/Talking Points - Day 2.pptx
+++ b/day2-deck/decks/Talking Points - Day 2.pptx
@@ -1681,7 +1681,7 @@
           <a:p>
             <a:r>
               <a:rPr lang="en-US" dirty="0"/>
-              <a:t>Source: Talking points: Service Manager Roundtable (Nov 15, 2024) and GM meeting decks (Jan and May 2026). Data: Qlik (Profit &amp; Loss, Closed Repair Orders, Productivity), Jan-Sep 2026 vs 2025, same-store, 33 stores, INEOS excluded.PLACE: Opcode Benchmarks, after MPI and Video Completion %, ahead of the op code closing % slides (moved out of Internal, Oct 23).
+              <a:t>Source: Talking points: Service Manager Roundtable (Nov 15, 2024) and GM meeting decks (Jan and May 2026). Data: Qlik (Profit &amp; Loss, Closed Repair Orders, Productivity), Jan-Sep 2026 vs 2025, same-store, 33 stores, INEOS excluded.PLACE: Opcode Benchmarks, after Basic Maintenance Service and ahead of MPI, Video and Photo Completion % (Noah, Oct 27: sets up the three inspection slides).
 Said: Jan GM slide 19 / May GM slide 15 (Tracking &amp; Accountability); Roundtable slide 16 (Performance Tracking).</a:t>
             </a:r>
             <a:endParaRPr lang="en-US" dirty="0"/>
@@ -11540,7 +11540,7 @@
         <p:spPr>
           <a:xfrm>
             <a:off x="7269480" y="1920240"/>
-            <a:ext cx="54864" cy="3794760"/>
+            <a:ext cx="54864" cy="1112520"/>
           </a:xfrm>
           <a:prstGeom prst="rect">
             <a:avLst/>
@@ -11601,7 +11601,7 @@
         <p:spPr>
           <a:xfrm>
             <a:off x="7452360" y="2441448"/>
-            <a:ext cx="4023360" cy="3291840"/>
+            <a:ext cx="4023360" cy="609600"/>
           </a:xfrm>
           <a:prstGeom prst="rect">
             <a:avLst/>
@@ -11639,6 +11639,206 @@
         </p:nvSpPr>
         <p:spPr>
           <a:xfrm>
+            <a:off x="7269480" y="3261360"/>
+            <a:ext cx="54864" cy="1112520"/>
+          </a:xfrm>
+          <a:prstGeom prst="rect">
+            <a:avLst/>
+          </a:prstGeom>
+          <a:solidFill>
+            <a:srgbClr val="2587C5"/>
+          </a:solidFill>
+          <a:ln/>
+        </p:spPr>
+      </p:sp>
+      <p:sp>
+        <p:nvSpPr>
+          <p:cNvPr id="14" name="Text 12"/>
+          <p:cNvSpPr txBox="1"/>
+          <p:nvPr/>
+        </p:nvSpPr>
+        <p:spPr>
+          <a:xfrm>
+            <a:off x="7452360" y="3215640"/>
+            <a:ext cx="4023360" cy="566928"/>
+          </a:xfrm>
+          <a:prstGeom prst="rect">
+            <a:avLst/>
+          </a:prstGeom>
+          <a:noFill/>
+          <a:ln/>
+        </p:spPr>
+        <p:txBody>
+          <a:bodyPr wrap="square" lIns="0" tIns="0" rIns="0" bIns="0" rtlCol="0" anchor="ctr">
+            <a:normAutofit/>
+          </a:bodyPr>
+          <a:lstStyle/>
+          <a:p>
+            <a:pPr indent="0" marL="0">
+              <a:buNone/>
+            </a:pPr>
+            <a:r>
+              <a:rPr lang="en-US" sz="3000" b="1" dirty="0">
+                <a:solidFill>
+                  <a:srgbClr val="0B2C4A"/>
+                </a:solidFill>
+                <a:latin typeface="Inter" pitchFamily="34" charset="0"/>
+                <a:ea typeface="Inter" pitchFamily="34" charset="-122"/>
+                <a:cs typeface="Inter" pitchFamily="34" charset="-120"/>
+              </a:rPr>
+              <a:t>57.8%</a:t>
+            </a:r>
+            <a:endParaRPr lang="en-US" sz="3000" dirty="0"/>
+          </a:p>
+        </p:txBody>
+      </p:sp>
+      <p:sp>
+        <p:nvSpPr>
+          <p:cNvPr id="15" name="Text 13"/>
+          <p:cNvSpPr txBox="1"/>
+          <p:nvPr/>
+        </p:nvSpPr>
+        <p:spPr>
+          <a:xfrm>
+            <a:off x="7452360" y="3782568"/>
+            <a:ext cx="4023360" cy="609600"/>
+          </a:xfrm>
+          <a:prstGeom prst="rect">
+            <a:avLst/>
+          </a:prstGeom>
+          <a:noFill/>
+          <a:ln/>
+        </p:spPr>
+        <p:txBody>
+          <a:bodyPr wrap="square" lIns="0" tIns="0" rIns="0" bIns="0" rtlCol="0" anchor="t"/>
+          <a:lstStyle/>
+          <a:p>
+            <a:pPr indent="0" marL="0">
+              <a:buNone/>
+            </a:pPr>
+            <a:r>
+              <a:rPr lang="en-US" sz="1400" dirty="0">
+                <a:solidFill>
+                  <a:srgbClr val="1A1A1A"/>
+                </a:solidFill>
+                <a:latin typeface="Inter" pitchFamily="34" charset="0"/>
+                <a:ea typeface="Inter" pitchFamily="34" charset="-122"/>
+                <a:cs typeface="Inter" pitchFamily="34" charset="-120"/>
+              </a:rPr>
+              <a:t>Video completion, July to September (store-reported). 17 of 33 stores at or above the group.</a:t>
+            </a:r>
+            <a:endParaRPr lang="en-US" sz="1400" dirty="0"/>
+          </a:p>
+        </p:txBody>
+      </p:sp>
+      <p:sp>
+        <p:nvSpPr>
+          <p:cNvPr id="16" name="Shape 14"/>
+          <p:cNvSpPr/>
+          <p:nvPr/>
+        </p:nvSpPr>
+        <p:spPr>
+          <a:xfrm>
+            <a:off x="7269480" y="4602480"/>
+            <a:ext cx="54864" cy="1112520"/>
+          </a:xfrm>
+          <a:prstGeom prst="rect">
+            <a:avLst/>
+          </a:prstGeom>
+          <a:solidFill>
+            <a:srgbClr val="2587C5"/>
+          </a:solidFill>
+          <a:ln/>
+        </p:spPr>
+      </p:sp>
+      <p:sp>
+        <p:nvSpPr>
+          <p:cNvPr id="17" name="Text 15"/>
+          <p:cNvSpPr txBox="1"/>
+          <p:nvPr/>
+        </p:nvSpPr>
+        <p:spPr>
+          <a:xfrm>
+            <a:off x="7452360" y="4556760"/>
+            <a:ext cx="4023360" cy="566928"/>
+          </a:xfrm>
+          <a:prstGeom prst="rect">
+            <a:avLst/>
+          </a:prstGeom>
+          <a:noFill/>
+          <a:ln/>
+        </p:spPr>
+        <p:txBody>
+          <a:bodyPr wrap="square" lIns="0" tIns="0" rIns="0" bIns="0" rtlCol="0" anchor="ctr">
+            <a:normAutofit/>
+          </a:bodyPr>
+          <a:lstStyle/>
+          <a:p>
+            <a:pPr indent="0" marL="0">
+              <a:buNone/>
+            </a:pPr>
+            <a:r>
+              <a:rPr lang="en-US" sz="3000" b="1" dirty="0">
+                <a:solidFill>
+                  <a:srgbClr val="0B2C4A"/>
+                </a:solidFill>
+                <a:latin typeface="Inter" pitchFamily="34" charset="0"/>
+                <a:ea typeface="Inter" pitchFamily="34" charset="-122"/>
+                <a:cs typeface="Inter" pitchFamily="34" charset="-120"/>
+              </a:rPr>
+              <a:t>45.3%</a:t>
+            </a:r>
+            <a:endParaRPr lang="en-US" sz="3000" dirty="0"/>
+          </a:p>
+        </p:txBody>
+      </p:sp>
+      <p:sp>
+        <p:nvSpPr>
+          <p:cNvPr id="18" name="Text 16"/>
+          <p:cNvSpPr txBox="1"/>
+          <p:nvPr/>
+        </p:nvSpPr>
+        <p:spPr>
+          <a:xfrm>
+            <a:off x="7452360" y="5123688"/>
+            <a:ext cx="4023360" cy="609600"/>
+          </a:xfrm>
+          <a:prstGeom prst="rect">
+            <a:avLst/>
+          </a:prstGeom>
+          <a:noFill/>
+          <a:ln/>
+        </p:spPr>
+        <p:txBody>
+          <a:bodyPr wrap="square" lIns="0" tIns="0" rIns="0" bIns="0" rtlCol="0" anchor="t"/>
+          <a:lstStyle/>
+          <a:p>
+            <a:pPr indent="0" marL="0">
+              <a:buNone/>
+            </a:pPr>
+            <a:r>
+              <a:rPr lang="en-US" sz="1400" dirty="0">
+                <a:solidFill>
+                  <a:srgbClr val="1A1A1A"/>
+                </a:solidFill>
+                <a:latin typeface="Inter" pitchFamily="34" charset="0"/>
+                <a:ea typeface="Inter" pitchFamily="34" charset="-122"/>
+                <a:cs typeface="Inter" pitchFamily="34" charset="-120"/>
+              </a:rPr>
+              <a:t>Photo completion, July to September. 11 of the 28 stores that report it at or above the group.</a:t>
+            </a:r>
+            <a:endParaRPr lang="en-US" sz="1400" dirty="0"/>
+          </a:p>
+        </p:txBody>
+      </p:sp>
+      <p:sp>
+        <p:nvSpPr>
+          <p:cNvPr id="19" name="Shape 17"/>
+          <p:cNvSpPr/>
+          <p:nvPr/>
+        </p:nvSpPr>
+        <p:spPr>
+          <a:xfrm>
             <a:off x="457200" y="6126480"/>
             <a:ext cx="11274552" cy="615696"/>
           </a:xfrm>
@@ -11653,7 +11853,7 @@
       </p:sp>
       <p:sp>
         <p:nvSpPr>
-          <p:cNvPr id="14" name="Text 12"/>
+          <p:cNvPr id="20" name="Text 18"/>
           <p:cNvSpPr txBox="1"/>
           <p:nvPr/>
         </p:nvSpPr>

</xml_diff>

<commit_message>
Why We Are Here same-store to match net profit slides; share to one decimal (round 47)
Co-Authored-By: Claude Opus 5.5 <noreply@anthropic.com>
Claude-Session: https://claude.ai/code/session_01Xa4nFVxuQGXmHARGph9WhS
</commit_message>
<xml_diff>
--- a/day2-deck/decks/Talking Points - Day 2.pptx
+++ b/day2-deck/decks/Talking Points - Day 2.pptx
@@ -516,7 +516,7 @@
           <a:p>
             <a:r>
               <a:rPr lang="en-US" dirty="0"/>
-              <a:t>Source: Qlik - Profit &amp; Loss, Jan-Sep 2026 vs 2025, all stores (INEOS included, to match the group P&amp;L), except the 27 cents vs 7 cents tile, which is same-store (INEOS excluded; 27 cents either way). Fixed ops = service (Mechanical) + parts (P&amp;A) department profit: department gross less the department's own expenses. Group net = Net Profit Or Loss on the GM statement.PLACE: right after the agenda, before the Gross section. In the deck Oct 24 (Noah): group net profit view replaces the gross / absorption / net-to-gross tiles. Group-level view of fixed ops' weight in the dealership's profit, Jan-Sep. Fixed ops department profit $50,194,950 (2025 $45,336,135); group net profit $82,240,434 (2025 $95,664,709). On the P&amp;L, F&amp;I income, other income and store-level costs are not split by department, so 'the rest of the store' is the group net less fixed ops department profit. Group net = Net Profit Or Loss on the GM statement (P&amp;L summary), all stores; INEOS (opened 2026) is in both lines. Body shop (GMC Prescott) department profit is left out of fixed ops, as everywhere in the deck.</a:t>
+              <a:t>Source: Qlik - Profit &amp; Loss, Jan-Sep 2026 vs 2025, same-store (INEOS excluded, opened 2026), as on the Fixed Ops Net Profit slides. Fixed ops = service (Mechanical) + parts (P&amp;A) department profit: department gross less the department's own expenses. Group net = Net Profit Or Loss on the GM statement.PLACE: right after the agenda, before the Gross section. In the deck Oct 24 (Noah): group net profit view replaces the gross / absorption / net-to-gross tiles. Group-level view of fixed ops' weight in the dealership's profit, Jan-Sep. Fixed ops department profit $50,449,894 (2025 $45,336,135); group net profit $82,743,115 (2025 $95,664,709). On the P&amp;L, F&amp;I income, other income and store-level costs are not split by department, so 'the rest of the store' is the group net less fixed ops department profit. Group net = Net Profit Or Loss on the GM statement (P&amp;L summary), same-store: INEOS (opened 2026) is out of both lines, as on the Fixed Ops Net Profit slides (Noah, Oct 29; all stores in, it was $50.19M of $82.24M). Body shop (GMC Prescott) department profit is left out of fixed ops, as everywhere in the deck.</a:t>
             </a:r>
             <a:endParaRPr lang="en-US" dirty="0"/>
           </a:p>
@@ -2565,7 +2565,7 @@
                 <a:ea typeface="Inter" pitchFamily="34" charset="-122"/>
                 <a:cs typeface="Inter" pitchFamily="34" charset="-120"/>
               </a:rPr>
-              <a:t>61%</a:t>
+              <a:t>61.0%</a:t>
             </a:r>
             <a:endParaRPr lang="en-US" sz="3000" dirty="0"/>
           </a:p>
@@ -2604,7 +2604,7 @@
                 <a:ea typeface="Inter" pitchFamily="34" charset="-122"/>
                 <a:cs typeface="Inter" pitchFamily="34" charset="-120"/>
               </a:rPr>
-              <a:t>of the group's net profit came from service and parts: $50.19M of $82.24M (47% in 2025).</a:t>
+              <a:t>of the group's net profit came from service and parts: $50.45M of $82.74M (47.4% in 2025).</a:t>
             </a:r>
             <a:endParaRPr lang="en-US" sz="1400" dirty="0"/>
           </a:p>
@@ -2765,7 +2765,7 @@
                 <a:ea typeface="Inter" pitchFamily="34" charset="-122"/>
                 <a:cs typeface="Inter" pitchFamily="34" charset="-120"/>
               </a:rPr>
-              <a:t>+$4,858,815</a:t>
+              <a:t>+$5,113,759</a:t>
             </a:r>
             <a:endParaRPr lang="en-US" sz="3000" dirty="0"/>
           </a:p>
@@ -2804,7 +2804,7 @@
                 <a:ea typeface="Inter" pitchFamily="34" charset="-122"/>
                 <a:cs typeface="Inter" pitchFamily="34" charset="-120"/>
               </a:rPr>
-              <a:t>More fixed ops profit than 2025, while group net profit fell $13.42M.</a:t>
+              <a:t>More fixed ops profit than 2025, while group net profit fell $12.92M.</a:t>
             </a:r>
             <a:endParaRPr lang="en-US" sz="1400" dirty="0"/>
           </a:p>

</xml_diff>

<commit_message>
Why We Are Here share back to whole percents (round 48)
Co-Authored-By: Claude Opus 5.5 <noreply@anthropic.com>
Claude-Session: https://claude.ai/code/session_01Xa4nFVxuQGXmHARGph9WhS
</commit_message>
<xml_diff>
--- a/day2-deck/decks/Talking Points - Day 2.pptx
+++ b/day2-deck/decks/Talking Points - Day 2.pptx
@@ -2565,7 +2565,7 @@
                 <a:ea typeface="Inter" pitchFamily="34" charset="-122"/>
                 <a:cs typeface="Inter" pitchFamily="34" charset="-120"/>
               </a:rPr>
-              <a:t>61.0%</a:t>
+              <a:t>61%</a:t>
             </a:r>
             <a:endParaRPr lang="en-US" sz="3000" dirty="0"/>
           </a:p>
@@ -2604,7 +2604,7 @@
                 <a:ea typeface="Inter" pitchFamily="34" charset="-122"/>
                 <a:cs typeface="Inter" pitchFamily="34" charset="-120"/>
               </a:rPr>
-              <a:t>of the group's net profit came from service and parts: $50.45M of $82.74M (47.4% in 2025).</a:t>
+              <a:t>of the group's net profit came from service and parts: $50.45M of $82.74M (47% in 2025).</a:t>
             </a:r>
             <a:endParaRPr lang="en-US" sz="1400" dirty="0"/>
           </a:p>

</xml_diff>